<commit_message>
Role tags on every container, arrangement flags, style contract
Shapes that are not fields are named after their role and the field they
hold ("card#2 > Heading 2", "panel#1 > Title", "decoration#5"); container
fields carry role= in the index. layouts.csv gains an `arrange` column
(row:3, grid:4, column:5:ordered) for the restyler. CI fills every field
at its limit in the default libraries and in the "soft" pack, and checks
roles, tokens and that packs keep ids and field names.
references/style-contract.md documents tokens, tags (shape name as
carrier, and why), arrangements and per-pack character limits.

Co-Authored-By: Claude Opus 5.5 <noreply@anthropic.com>
Claude-Session: https://claude.ai/code/session_01QPUPqERJ7izWceAQmUT86B
</commit_message>
<xml_diff>
--- a/skills/make-clean-pptx/assets/layouts.pptx
+++ b/skills/make-clean-pptx/assets/layouts.pptx
@@ -5921,7 +5921,7 @@
       </p:sp>
       <p:sp>
         <p:nvSpPr>
-          <p:cNvPr id="6" name="Decoration 1">
+          <p:cNvPr id="6" name="decoration#1">
             <a:extLst>
               <a:ext uri="{C183D7F6-B498-43B3-948B-1728B52AA6E4}">
                 <adec:decorative xmlns:adec="http://schemas.microsoft.com/office/drawing/2017/decorative" val="1"/>
@@ -6152,7 +6152,7 @@
       </p:sp>
       <p:sp>
         <p:nvSpPr>
-          <p:cNvPr id="4" name="Decoration 1">
+          <p:cNvPr id="4" name="decoration#1">
             <a:extLst>
               <a:ext uri="{C183D7F6-B498-43B3-948B-1728B52AA6E4}">
                 <adec:decorative xmlns:adec="http://schemas.microsoft.com/office/drawing/2017/decorative" val="1"/>
@@ -6666,7 +6666,7 @@
       </p:sp>
       <p:sp>
         <p:nvSpPr>
-          <p:cNvPr id="7" name="Decoration 1">
+          <p:cNvPr id="7" name="decoration#1">
             <a:extLst>
               <a:ext uri="{C183D7F6-B498-43B3-948B-1728B52AA6E4}">
                 <adec:decorative xmlns:adec="http://schemas.microsoft.com/office/drawing/2017/decorative" val="1"/>
@@ -6909,7 +6909,7 @@
       </p:grpSpPr>
       <p:sp>
         <p:nvSpPr>
-          <p:cNvPr id="2" name="Decoration 1">
+          <p:cNvPr id="2" name="decoration#1">
             <a:extLst>
               <a:ext uri="{C183D7F6-B498-43B3-948B-1728B52AA6E4}">
                 <adec:decorative xmlns:adec="http://schemas.microsoft.com/office/drawing/2017/decorative" val="1"/>
@@ -7323,7 +7323,7 @@
       </p:sp>
       <p:sp>
         <p:nvSpPr>
-          <p:cNvPr id="6" name="Decoration 1">
+          <p:cNvPr id="6" name="decoration#1">
             <a:extLst>
               <a:ext uri="{C183D7F6-B498-43B3-948B-1728B52AA6E4}">
                 <adec:decorative xmlns:adec="http://schemas.microsoft.com/office/drawing/2017/decorative" val="1"/>
@@ -7514,7 +7514,7 @@
       </p:grpSpPr>
       <p:sp>
         <p:nvSpPr>
-          <p:cNvPr id="2" name="Decoration 1">
+          <p:cNvPr id="2" name="decoration#1">
             <a:extLst>
               <a:ext uri="{C183D7F6-B498-43B3-948B-1728B52AA6E4}">
                 <adec:decorative xmlns:adec="http://schemas.microsoft.com/office/drawing/2017/decorative" val="1"/>
@@ -9466,7 +9466,13 @@
       </p:sp>
       <p:sp>
         <p:nvSpPr>
-          <p:cNvPr id="7" name="Side rule"/>
+          <p:cNvPr id="7" name="decoration#1">
+            <a:extLst>
+              <a:ext uri="{C183D7F6-B498-43B3-948B-1728B52AA6E4}">
+                <adec:decorative xmlns:adec="http://schemas.microsoft.com/office/drawing/2017/decorative" val="1"/>
+              </a:ext>
+            </a:extLst>
+          </p:cNvPr>
           <p:cNvSpPr/>
           <p:nvPr/>
         </p:nvSpPr>
@@ -9786,7 +9792,7 @@
       </p:sp>
       <p:sp>
         <p:nvSpPr>
-          <p:cNvPr id="6" name="Decoration 1">
+          <p:cNvPr id="6" name="decoration#1">
             <a:extLst>
               <a:ext uri="{C183D7F6-B498-43B3-948B-1728B52AA6E4}">
                 <adec:decorative xmlns:adec="http://schemas.microsoft.com/office/drawing/2017/decorative" val="1"/>
@@ -9951,7 +9957,7 @@
       </p:sp>
       <p:sp>
         <p:nvSpPr>
-          <p:cNvPr id="9" name="Decoration 2">
+          <p:cNvPr id="9" name="decoration#2">
             <a:extLst>
               <a:ext uri="{C183D7F6-B498-43B3-948B-1728B52AA6E4}">
                 <adec:decorative xmlns:adec="http://schemas.microsoft.com/office/drawing/2017/decorative" val="1"/>
@@ -10325,7 +10331,7 @@
       </p:sp>
       <p:sp>
         <p:nvSpPr>
-          <p:cNvPr id="5" name="Decoration 1">
+          <p:cNvPr id="5" name="decoration#1">
             <a:extLst>
               <a:ext uri="{C183D7F6-B498-43B3-948B-1728B52AA6E4}">
                 <adec:decorative xmlns:adec="http://schemas.microsoft.com/office/drawing/2017/decorative" val="1"/>
@@ -11334,7 +11340,7 @@
       </p:sp>
       <p:sp>
         <p:nvSpPr>
-          <p:cNvPr id="9" name="Decoration 1">
+          <p:cNvPr id="9" name="decoration#1">
             <a:extLst>
               <a:ext uri="{C183D7F6-B498-43B3-948B-1728B52AA6E4}">
                 <adec:decorative xmlns:adec="http://schemas.microsoft.com/office/drawing/2017/decorative" val="1"/>
@@ -11494,7 +11500,7 @@
       </p:sp>
       <p:sp>
         <p:nvSpPr>
-          <p:cNvPr id="13" name="Decoration 2">
+          <p:cNvPr id="13" name="decoration#2">
             <a:extLst>
               <a:ext uri="{C183D7F6-B498-43B3-948B-1728B52AA6E4}">
                 <adec:decorative xmlns:adec="http://schemas.microsoft.com/office/drawing/2017/decorative" val="1"/>
@@ -11654,7 +11660,7 @@
       </p:sp>
       <p:sp>
         <p:nvSpPr>
-          <p:cNvPr id="17" name="Decoration 3">
+          <p:cNvPr id="17" name="decoration#3">
             <a:extLst>
               <a:ext uri="{C183D7F6-B498-43B3-948B-1728B52AA6E4}">
                 <adec:decorative xmlns:adec="http://schemas.microsoft.com/office/drawing/2017/decorative" val="1"/>
@@ -12022,7 +12028,7 @@
       </p:sp>
       <p:sp>
         <p:nvSpPr>
-          <p:cNvPr id="5" name="Decoration 1">
+          <p:cNvPr id="5" name="card#1 &gt; Heading 1">
             <a:extLst>
               <a:ext uri="{C183D7F6-B498-43B3-948B-1728B52AA6E4}">
                 <adec:decorative xmlns:adec="http://schemas.microsoft.com/office/drawing/2017/decorative" val="1"/>
@@ -12132,7 +12138,7 @@
       </p:sp>
       <p:sp>
         <p:nvSpPr>
-          <p:cNvPr id="8" name="Decoration 2">
+          <p:cNvPr id="8" name="card#2 &gt; Heading 2">
             <a:extLst>
               <a:ext uri="{C183D7F6-B498-43B3-948B-1728B52AA6E4}">
                 <adec:decorative xmlns:adec="http://schemas.microsoft.com/office/drawing/2017/decorative" val="1"/>
@@ -12242,7 +12248,7 @@
       </p:sp>
       <p:sp>
         <p:nvSpPr>
-          <p:cNvPr id="11" name="Decoration 3">
+          <p:cNvPr id="11" name="card#3 &gt; Heading 3">
             <a:extLst>
               <a:ext uri="{C183D7F6-B498-43B3-948B-1728B52AA6E4}">
                 <adec:decorative xmlns:adec="http://schemas.microsoft.com/office/drawing/2017/decorative" val="1"/>
@@ -12352,7 +12358,7 @@
       </p:sp>
       <p:sp>
         <p:nvSpPr>
-          <p:cNvPr id="14" name="Decoration 4">
+          <p:cNvPr id="14" name="card#4 &gt; Heading 4">
             <a:extLst>
               <a:ext uri="{C183D7F6-B498-43B3-948B-1728B52AA6E4}">
                 <adec:decorative xmlns:adec="http://schemas.microsoft.com/office/drawing/2017/decorative" val="1"/>
@@ -12712,7 +12718,7 @@
       </p:sp>
       <p:sp>
         <p:nvSpPr>
-          <p:cNvPr id="6" name="Decoration 1">
+          <p:cNvPr id="6" name="panel#1 &gt; Sidebar">
             <a:extLst>
               <a:ext uri="{C183D7F6-B498-43B3-948B-1728B52AA6E4}">
                 <adec:decorative xmlns:adec="http://schemas.microsoft.com/office/drawing/2017/decorative" val="1"/>
@@ -13179,7 +13185,7 @@
       </p:sp>
       <p:sp>
         <p:nvSpPr>
-          <p:cNvPr id="6" name="Decoration 1">
+          <p:cNvPr id="6" name="callout#1 &gt; Takeaway">
             <a:extLst>
               <a:ext uri="{C183D7F6-B498-43B3-948B-1728B52AA6E4}">
                 <adec:decorative xmlns:adec="http://schemas.microsoft.com/office/drawing/2017/decorative" val="1"/>
@@ -13584,7 +13590,7 @@
       </p:sp>
       <p:sp>
         <p:nvSpPr>
-          <p:cNvPr id="7" name="Decoration 1">
+          <p:cNvPr id="7" name="decoration#1">
             <a:extLst>
               <a:ext uri="{C183D7F6-B498-43B3-948B-1728B52AA6E4}">
                 <adec:decorative xmlns:adec="http://schemas.microsoft.com/office/drawing/2017/decorative" val="1"/>
@@ -14225,7 +14231,7 @@
       </p:sp>
       <p:sp>
         <p:nvSpPr>
-          <p:cNvPr id="5" name="Decoration 1">
+          <p:cNvPr id="5" name="callout#1 &gt; Problem">
             <a:extLst>
               <a:ext uri="{C183D7F6-B498-43B3-948B-1728B52AA6E4}">
                 <adec:decorative xmlns:adec="http://schemas.microsoft.com/office/drawing/2017/decorative" val="1"/>
@@ -15040,7 +15046,7 @@
       </p:sp>
       <p:sp>
         <p:nvSpPr>
-          <p:cNvPr id="3" name="Decoration 1">
+          <p:cNvPr id="3" name="callout#1 &gt; Title">
             <a:extLst>
               <a:ext uri="{C183D7F6-B498-43B3-948B-1728B52AA6E4}">
                 <adec:decorative xmlns:adec="http://schemas.microsoft.com/office/drawing/2017/decorative" val="1"/>
@@ -15829,7 +15835,7 @@
       </p:grpSpPr>
       <p:sp>
         <p:nvSpPr>
-          <p:cNvPr id="2" name="Decoration 1">
+          <p:cNvPr id="2" name="decoration#1">
             <a:extLst>
               <a:ext uri="{C183D7F6-B498-43B3-948B-1728B52AA6E4}">
                 <adec:decorative xmlns:adec="http://schemas.microsoft.com/office/drawing/2017/decorative" val="1"/>
@@ -15942,7 +15948,7 @@
       </p:sp>
       <p:sp>
         <p:nvSpPr>
-          <p:cNvPr id="5" name="Decoration 2">
+          <p:cNvPr id="5" name="decoration#2">
             <a:extLst>
               <a:ext uri="{C183D7F6-B498-43B3-948B-1728B52AA6E4}">
                 <adec:decorative xmlns:adec="http://schemas.microsoft.com/office/drawing/2017/decorative" val="1"/>
@@ -17406,7 +17412,7 @@
       </p:sp>
       <p:sp>
         <p:nvSpPr>
-          <p:cNvPr id="8" name="Decoration 1">
+          <p:cNvPr id="8" name="decoration#1">
             <a:extLst>
               <a:ext uri="{C183D7F6-B498-43B3-948B-1728B52AA6E4}">
                 <adec:decorative xmlns:adec="http://schemas.microsoft.com/office/drawing/2017/decorative" val="1"/>
@@ -18607,7 +18613,7 @@
       </p:sp>
       <p:sp>
         <p:nvSpPr>
-          <p:cNvPr id="6" name="Decoration 1">
+          <p:cNvPr id="6" name="decoration#1">
             <a:extLst>
               <a:ext uri="{C183D7F6-B498-43B3-948B-1728B52AA6E4}">
                 <adec:decorative xmlns:adec="http://schemas.microsoft.com/office/drawing/2017/decorative" val="1"/>
@@ -18765,7 +18771,7 @@
       </p:sp>
       <p:sp>
         <p:nvSpPr>
-          <p:cNvPr id="10" name="Decoration 2">
+          <p:cNvPr id="10" name="decoration#2">
             <a:extLst>
               <a:ext uri="{C183D7F6-B498-43B3-948B-1728B52AA6E4}">
                 <adec:decorative xmlns:adec="http://schemas.microsoft.com/office/drawing/2017/decorative" val="1"/>
@@ -19629,7 +19635,7 @@
       </p:sp>
       <p:sp>
         <p:nvSpPr>
-          <p:cNvPr id="6" name="Decoration 1">
+          <p:cNvPr id="6" name="decoration#1">
             <a:extLst>
               <a:ext uri="{C183D7F6-B498-43B3-948B-1728B52AA6E4}">
                 <adec:decorative xmlns:adec="http://schemas.microsoft.com/office/drawing/2017/decorative" val="1"/>
@@ -19787,7 +19793,7 @@
       </p:sp>
       <p:sp>
         <p:nvSpPr>
-          <p:cNvPr id="10" name="Decoration 2">
+          <p:cNvPr id="10" name="decoration#2">
             <a:extLst>
               <a:ext uri="{C183D7F6-B498-43B3-948B-1728B52AA6E4}">
                 <adec:decorative xmlns:adec="http://schemas.microsoft.com/office/drawing/2017/decorative" val="1"/>
@@ -19945,7 +19951,7 @@
       </p:sp>
       <p:sp>
         <p:nvSpPr>
-          <p:cNvPr id="14" name="Decoration 3">
+          <p:cNvPr id="14" name="decoration#3">
             <a:extLst>
               <a:ext uri="{C183D7F6-B498-43B3-948B-1728B52AA6E4}">
                 <adec:decorative xmlns:adec="http://schemas.microsoft.com/office/drawing/2017/decorative" val="1"/>
@@ -20353,7 +20359,7 @@
       </p:sp>
       <p:sp>
         <p:nvSpPr>
-          <p:cNvPr id="6" name="Decoration 1">
+          <p:cNvPr id="6" name="keyfigure#1 &gt; KPI 1 value">
             <a:extLst>
               <a:ext uri="{C183D7F6-B498-43B3-948B-1728B52AA6E4}">
                 <adec:decorative xmlns:adec="http://schemas.microsoft.com/office/drawing/2017/decorative" val="1"/>
@@ -20508,7 +20514,7 @@
       </p:sp>
       <p:sp>
         <p:nvSpPr>
-          <p:cNvPr id="10" name="Decoration 2">
+          <p:cNvPr id="10" name="keyfigure#2 &gt; KPI 2 value">
             <a:extLst>
               <a:ext uri="{C183D7F6-B498-43B3-948B-1728B52AA6E4}">
                 <adec:decorative xmlns:adec="http://schemas.microsoft.com/office/drawing/2017/decorative" val="1"/>
@@ -20663,7 +20669,7 @@
       </p:sp>
       <p:sp>
         <p:nvSpPr>
-          <p:cNvPr id="14" name="Decoration 3">
+          <p:cNvPr id="14" name="keyfigure#3 &gt; KPI 3 value">
             <a:extLst>
               <a:ext uri="{C183D7F6-B498-43B3-948B-1728B52AA6E4}">
                 <adec:decorative xmlns:adec="http://schemas.microsoft.com/office/drawing/2017/decorative" val="1"/>
@@ -20818,7 +20824,7 @@
       </p:sp>
       <p:sp>
         <p:nvSpPr>
-          <p:cNvPr id="18" name="Decoration 4">
+          <p:cNvPr id="18" name="keyfigure#4 &gt; KPI 4 value">
             <a:extLst>
               <a:ext uri="{C183D7F6-B498-43B3-948B-1728B52AA6E4}">
                 <adec:decorative xmlns:adec="http://schemas.microsoft.com/office/drawing/2017/decorative" val="1"/>
@@ -21181,7 +21187,7 @@
       </p:sp>
       <p:sp>
         <p:nvSpPr>
-          <p:cNvPr id="5" name="Decoration 1">
+          <p:cNvPr id="5" name="decoration#1">
             <a:extLst>
               <a:ext uri="{C183D7F6-B498-43B3-948B-1728B52AA6E4}">
                 <adec:decorative xmlns:adec="http://schemas.microsoft.com/office/drawing/2017/decorative" val="1"/>
@@ -21341,7 +21347,7 @@
       </p:sp>
       <p:sp>
         <p:nvSpPr>
-          <p:cNvPr id="9" name="Decoration 2">
+          <p:cNvPr id="9" name="decoration#2">
             <a:extLst>
               <a:ext uri="{C183D7F6-B498-43B3-948B-1728B52AA6E4}">
                 <adec:decorative xmlns:adec="http://schemas.microsoft.com/office/drawing/2017/decorative" val="1"/>
@@ -21501,7 +21507,7 @@
       </p:sp>
       <p:sp>
         <p:nvSpPr>
-          <p:cNvPr id="13" name="Decoration 3">
+          <p:cNvPr id="13" name="decoration#3">
             <a:extLst>
               <a:ext uri="{C183D7F6-B498-43B3-948B-1728B52AA6E4}">
                 <adec:decorative xmlns:adec="http://schemas.microsoft.com/office/drawing/2017/decorative" val="1"/>
@@ -21661,7 +21667,7 @@
       </p:sp>
       <p:sp>
         <p:nvSpPr>
-          <p:cNvPr id="17" name="Decoration 4">
+          <p:cNvPr id="17" name="decoration#4">
             <a:extLst>
               <a:ext uri="{C183D7F6-B498-43B3-948B-1728B52AA6E4}">
                 <adec:decorative xmlns:adec="http://schemas.microsoft.com/office/drawing/2017/decorative" val="1"/>
@@ -21821,7 +21827,7 @@
       </p:sp>
       <p:sp>
         <p:nvSpPr>
-          <p:cNvPr id="21" name="Decoration 5">
+          <p:cNvPr id="21" name="decoration#5">
             <a:extLst>
               <a:ext uri="{C183D7F6-B498-43B3-948B-1728B52AA6E4}">
                 <adec:decorative xmlns:adec="http://schemas.microsoft.com/office/drawing/2017/decorative" val="1"/>
@@ -21981,7 +21987,7 @@
       </p:sp>
       <p:sp>
         <p:nvSpPr>
-          <p:cNvPr id="25" name="Decoration 6">
+          <p:cNvPr id="25" name="decoration#6">
             <a:extLst>
               <a:ext uri="{C183D7F6-B498-43B3-948B-1728B52AA6E4}">
                 <adec:decorative xmlns:adec="http://schemas.microsoft.com/office/drawing/2017/decorative" val="1"/>
@@ -22481,7 +22487,7 @@
       </p:grpSpPr>
       <p:sp>
         <p:nvSpPr>
-          <p:cNvPr id="2" name="Decoration 1">
+          <p:cNvPr id="2" name="panel#1 &gt; Number">
             <a:extLst>
               <a:ext uri="{C183D7F6-B498-43B3-948B-1728B52AA6E4}">
                 <adec:decorative xmlns:adec="http://schemas.microsoft.com/office/drawing/2017/decorative" val="1"/>
@@ -27288,7 +27294,7 @@
       </p:sp>
       <p:sp>
         <p:nvSpPr>
-          <p:cNvPr id="5" name="Decoration 1">
+          <p:cNvPr id="5" name="card#1 &gt; Option 1 name">
             <a:extLst>
               <a:ext uri="{C183D7F6-B498-43B3-948B-1728B52AA6E4}">
                 <adec:decorative xmlns:adec="http://schemas.microsoft.com/office/drawing/2017/decorative" val="1"/>
@@ -27499,7 +27505,7 @@
       </p:sp>
       <p:sp>
         <p:nvSpPr>
-          <p:cNvPr id="9" name="Decoration 2">
+          <p:cNvPr id="9" name="decoration#1">
             <a:extLst>
               <a:ext uri="{C183D7F6-B498-43B3-948B-1728B52AA6E4}">
                 <adec:decorative xmlns:adec="http://schemas.microsoft.com/office/drawing/2017/decorative" val="1"/>
@@ -27572,7 +27578,7 @@
       </p:sp>
       <p:sp>
         <p:nvSpPr>
-          <p:cNvPr id="11" name="Decoration 3">
+          <p:cNvPr id="11" name="card#2 &gt; Option 2 name">
             <a:extLst>
               <a:ext uri="{C183D7F6-B498-43B3-948B-1728B52AA6E4}">
                 <adec:decorative xmlns:adec="http://schemas.microsoft.com/office/drawing/2017/decorative" val="1"/>
@@ -27783,7 +27789,7 @@
       </p:sp>
       <p:sp>
         <p:nvSpPr>
-          <p:cNvPr id="15" name="Decoration 4">
+          <p:cNvPr id="15" name="decoration#2">
             <a:extLst>
               <a:ext uri="{C183D7F6-B498-43B3-948B-1728B52AA6E4}">
                 <adec:decorative xmlns:adec="http://schemas.microsoft.com/office/drawing/2017/decorative" val="1"/>
@@ -28064,7 +28070,7 @@
       </p:sp>
       <p:sp>
         <p:nvSpPr>
-          <p:cNvPr id="5" name="Decoration 1">
+          <p:cNvPr id="5" name="card#1 &gt; Option 1 name">
             <a:extLst>
               <a:ext uri="{C183D7F6-B498-43B3-948B-1728B52AA6E4}">
                 <adec:decorative xmlns:adec="http://schemas.microsoft.com/office/drawing/2017/decorative" val="1"/>
@@ -28268,7 +28274,7 @@
       </p:sp>
       <p:sp>
         <p:nvSpPr>
-          <p:cNvPr id="9" name="Decoration 2">
+          <p:cNvPr id="9" name="decoration#1">
             <a:extLst>
               <a:ext uri="{C183D7F6-B498-43B3-948B-1728B52AA6E4}">
                 <adec:decorative xmlns:adec="http://schemas.microsoft.com/office/drawing/2017/decorative" val="1"/>
@@ -28339,7 +28345,7 @@
       </p:sp>
       <p:sp>
         <p:nvSpPr>
-          <p:cNvPr id="11" name="Decoration 3">
+          <p:cNvPr id="11" name="card#2 &gt; Option 2 name">
             <a:extLst>
               <a:ext uri="{C183D7F6-B498-43B3-948B-1728B52AA6E4}">
                 <adec:decorative xmlns:adec="http://schemas.microsoft.com/office/drawing/2017/decorative" val="1"/>
@@ -28550,7 +28556,7 @@
       </p:sp>
       <p:sp>
         <p:nvSpPr>
-          <p:cNvPr id="15" name="Decoration 4">
+          <p:cNvPr id="15" name="decoration#2">
             <a:extLst>
               <a:ext uri="{C183D7F6-B498-43B3-948B-1728B52AA6E4}">
                 <adec:decorative xmlns:adec="http://schemas.microsoft.com/office/drawing/2017/decorative" val="1"/>
@@ -28831,7 +28837,7 @@
       </p:sp>
       <p:sp>
         <p:nvSpPr>
-          <p:cNvPr id="5" name="Decoration 1">
+          <p:cNvPr id="5" name="card#1 &gt; Option 1 name">
             <a:extLst>
               <a:ext uri="{C183D7F6-B498-43B3-948B-1728B52AA6E4}">
                 <adec:decorative xmlns:adec="http://schemas.microsoft.com/office/drawing/2017/decorative" val="1"/>
@@ -29042,7 +29048,7 @@
       </p:sp>
       <p:sp>
         <p:nvSpPr>
-          <p:cNvPr id="9" name="Decoration 2">
+          <p:cNvPr id="9" name="decoration#1">
             <a:extLst>
               <a:ext uri="{C183D7F6-B498-43B3-948B-1728B52AA6E4}">
                 <adec:decorative xmlns:adec="http://schemas.microsoft.com/office/drawing/2017/decorative" val="1"/>
@@ -29115,7 +29121,7 @@
       </p:sp>
       <p:sp>
         <p:nvSpPr>
-          <p:cNvPr id="11" name="Decoration 3">
+          <p:cNvPr id="11" name="card#2 &gt; Option 2 name">
             <a:extLst>
               <a:ext uri="{C183D7F6-B498-43B3-948B-1728B52AA6E4}">
                 <adec:decorative xmlns:adec="http://schemas.microsoft.com/office/drawing/2017/decorative" val="1"/>
@@ -29326,7 +29332,7 @@
       </p:sp>
       <p:sp>
         <p:nvSpPr>
-          <p:cNvPr id="15" name="Decoration 4">
+          <p:cNvPr id="15" name="decoration#2">
             <a:extLst>
               <a:ext uri="{C183D7F6-B498-43B3-948B-1728B52AA6E4}">
                 <adec:decorative xmlns:adec="http://schemas.microsoft.com/office/drawing/2017/decorative" val="1"/>
@@ -29399,7 +29405,7 @@
       </p:sp>
       <p:sp>
         <p:nvSpPr>
-          <p:cNvPr id="17" name="Decoration 5">
+          <p:cNvPr id="17" name="card#3 &gt; Option 3 name">
             <a:extLst>
               <a:ext uri="{C183D7F6-B498-43B3-948B-1728B52AA6E4}">
                 <adec:decorative xmlns:adec="http://schemas.microsoft.com/office/drawing/2017/decorative" val="1"/>
@@ -29610,7 +29616,7 @@
       </p:sp>
       <p:sp>
         <p:nvSpPr>
-          <p:cNvPr id="21" name="Decoration 6">
+          <p:cNvPr id="21" name="decoration#3">
             <a:extLst>
               <a:ext uri="{C183D7F6-B498-43B3-948B-1728B52AA6E4}">
                 <adec:decorative xmlns:adec="http://schemas.microsoft.com/office/drawing/2017/decorative" val="1"/>
@@ -29891,7 +29897,7 @@
       </p:sp>
       <p:sp>
         <p:nvSpPr>
-          <p:cNvPr id="5" name="Decoration 1">
+          <p:cNvPr id="5" name="card#1 &gt; Left points">
             <a:extLst>
               <a:ext uri="{C183D7F6-B498-43B3-948B-1728B52AA6E4}">
                 <adec:decorative xmlns:adec="http://schemas.microsoft.com/office/drawing/2017/decorative" val="1"/>
@@ -30056,7 +30062,7 @@
       </p:sp>
       <p:sp>
         <p:nvSpPr>
-          <p:cNvPr id="8" name="Decoration 2">
+          <p:cNvPr id="8" name="decoration#1">
             <a:extLst>
               <a:ext uri="{C183D7F6-B498-43B3-948B-1728B52AA6E4}">
                 <adec:decorative xmlns:adec="http://schemas.microsoft.com/office/drawing/2017/decorative" val="1"/>
@@ -30086,7 +30092,7 @@
       </p:sp>
       <p:sp>
         <p:nvSpPr>
-          <p:cNvPr id="9" name="Decoration 3">
+          <p:cNvPr id="9" name="card#2 &gt; Right points">
             <a:extLst>
               <a:ext uri="{C183D7F6-B498-43B3-948B-1728B52AA6E4}">
                 <adec:decorative xmlns:adec="http://schemas.microsoft.com/office/drawing/2017/decorative" val="1"/>
@@ -30456,7 +30462,7 @@
       </p:sp>
       <p:sp>
         <p:nvSpPr>
-          <p:cNvPr id="5" name="Decoration 1">
+          <p:cNvPr id="5" name="decoration#1">
             <a:extLst>
               <a:ext uri="{C183D7F6-B498-43B3-948B-1728B52AA6E4}">
                 <adec:decorative xmlns:adec="http://schemas.microsoft.com/office/drawing/2017/decorative" val="1"/>
@@ -30926,7 +30932,7 @@
       </p:sp>
       <p:sp>
         <p:nvSpPr>
-          <p:cNvPr id="17" name="Decoration 2">
+          <p:cNvPr id="17" name="callout#1 &gt; Decision">
             <a:extLst>
               <a:ext uri="{C183D7F6-B498-43B3-948B-1728B52AA6E4}">
                 <adec:decorative xmlns:adec="http://schemas.microsoft.com/office/drawing/2017/decorative" val="1"/>
@@ -31286,7 +31292,7 @@
       </p:sp>
       <p:sp>
         <p:nvSpPr>
-          <p:cNvPr id="6" name="Decoration 1">
+          <p:cNvPr id="6" name="decoration#1">
             <a:extLst>
               <a:ext uri="{C183D7F6-B498-43B3-948B-1728B52AA6E4}">
                 <adec:decorative xmlns:adec="http://schemas.microsoft.com/office/drawing/2017/decorative" val="1"/>
@@ -32283,7 +32289,7 @@
       </p:sp>
       <p:sp>
         <p:nvSpPr>
-          <p:cNvPr id="4" name="Decoration 1">
+          <p:cNvPr id="4" name="decoration#1">
             <a:extLst>
               <a:ext uri="{C183D7F6-B498-43B3-948B-1728B52AA6E4}">
                 <adec:decorative xmlns:adec="http://schemas.microsoft.com/office/drawing/2017/decorative" val="1"/>
@@ -32820,7 +32826,7 @@
       </p:grpSpPr>
       <p:sp>
         <p:nvSpPr>
-          <p:cNvPr id="2" name="Decoration 1">
+          <p:cNvPr id="2" name="panel#1 &gt; Title">
             <a:extLst>
               <a:ext uri="{C183D7F6-B498-43B3-948B-1728B52AA6E4}">
                 <adec:decorative xmlns:adec="http://schemas.microsoft.com/office/drawing/2017/decorative" val="1"/>
@@ -33216,7 +33222,7 @@
       </p:sp>
       <p:sp>
         <p:nvSpPr>
-          <p:cNvPr id="5" name="Decoration 1">
+          <p:cNvPr id="5" name="keyfigure#1 &gt; Main value">
             <a:extLst>
               <a:ext uri="{C183D7F6-B498-43B3-948B-1728B52AA6E4}">
                 <adec:decorative xmlns:adec="http://schemas.microsoft.com/office/drawing/2017/decorative" val="1"/>
@@ -33368,7 +33374,7 @@
       </p:sp>
       <p:sp>
         <p:nvSpPr>
-          <p:cNvPr id="9" name="Decoration 2">
+          <p:cNvPr id="9" name="card#1 &gt; Tile 1 heading">
             <a:extLst>
               <a:ext uri="{C183D7F6-B498-43B3-948B-1728B52AA6E4}">
                 <adec:decorative xmlns:adec="http://schemas.microsoft.com/office/drawing/2017/decorative" val="1"/>
@@ -33478,7 +33484,7 @@
       </p:sp>
       <p:sp>
         <p:nvSpPr>
-          <p:cNvPr id="12" name="Decoration 3">
+          <p:cNvPr id="12" name="card#2 &gt; Tile 2 heading">
             <a:extLst>
               <a:ext uri="{C183D7F6-B498-43B3-948B-1728B52AA6E4}">
                 <adec:decorative xmlns:adec="http://schemas.microsoft.com/office/drawing/2017/decorative" val="1"/>
@@ -33588,7 +33594,7 @@
       </p:sp>
       <p:sp>
         <p:nvSpPr>
-          <p:cNvPr id="15" name="Decoration 4">
+          <p:cNvPr id="15" name="card#3 &gt; Tile 3 heading">
             <a:extLst>
               <a:ext uri="{C183D7F6-B498-43B3-948B-1728B52AA6E4}">
                 <adec:decorative xmlns:adec="http://schemas.microsoft.com/office/drawing/2017/decorative" val="1"/>
@@ -33906,7 +33912,7 @@
       </p:sp>
       <p:sp>
         <p:nvSpPr>
-          <p:cNvPr id="5" name="Decoration 1">
+          <p:cNvPr id="5" name="panel#1 &gt; Band 1 heading">
             <a:extLst>
               <a:ext uri="{C183D7F6-B498-43B3-948B-1728B52AA6E4}">
                 <adec:decorative xmlns:adec="http://schemas.microsoft.com/office/drawing/2017/decorative" val="1"/>
@@ -34184,7 +34190,7 @@
       </p:sp>
       <p:sp>
         <p:nvSpPr>
-          <p:cNvPr id="12" name="Decoration 2">
+          <p:cNvPr id="12" name="panel#2 &gt; Band 3 heading">
             <a:extLst>
               <a:ext uri="{C183D7F6-B498-43B3-948B-1728B52AA6E4}">
                 <adec:decorative xmlns:adec="http://schemas.microsoft.com/office/drawing/2017/decorative" val="1"/>
@@ -34544,7 +34550,7 @@
       </p:sp>
       <p:sp>
         <p:nvSpPr>
-          <p:cNvPr id="5" name="Decoration 1">
+          <p:cNvPr id="5" name="decoration#1">
             <a:extLst>
               <a:ext uri="{C183D7F6-B498-43B3-948B-1728B52AA6E4}">
                 <adec:decorative xmlns:adec="http://schemas.microsoft.com/office/drawing/2017/decorative" val="1"/>
@@ -35279,7 +35285,7 @@
       </p:grpSpPr>
       <p:sp>
         <p:nvSpPr>
-          <p:cNvPr id="2" name="Decoration 1">
+          <p:cNvPr id="2" name="panel#1 &gt; Title">
             <a:extLst>
               <a:ext uri="{C183D7F6-B498-43B3-948B-1728B52AA6E4}">
                 <adec:decorative xmlns:adec="http://schemas.microsoft.com/office/drawing/2017/decorative" val="1"/>
@@ -35431,7 +35437,7 @@
       </p:sp>
       <p:sp>
         <p:nvSpPr>
-          <p:cNvPr id="6" name="Decoration 2">
+          <p:cNvPr id="6" name="decoration#1">
             <a:extLst>
               <a:ext uri="{C183D7F6-B498-43B3-948B-1728B52AA6E4}">
                 <adec:decorative xmlns:adec="http://schemas.microsoft.com/office/drawing/2017/decorative" val="1"/>
@@ -35544,7 +35550,7 @@
       </p:sp>
       <p:sp>
         <p:nvSpPr>
-          <p:cNvPr id="9" name="Decoration 3">
+          <p:cNvPr id="9" name="decoration#2">
             <a:extLst>
               <a:ext uri="{C183D7F6-B498-43B3-948B-1728B52AA6E4}">
                 <adec:decorative xmlns:adec="http://schemas.microsoft.com/office/drawing/2017/decorative" val="1"/>
@@ -35856,7 +35862,7 @@
       </p:sp>
       <p:sp>
         <p:nvSpPr>
-          <p:cNvPr id="5" name="Decoration 1">
+          <p:cNvPr id="5" name="decoration#1">
             <a:extLst>
               <a:ext uri="{C183D7F6-B498-43B3-948B-1728B52AA6E4}">
                 <adec:decorative xmlns:adec="http://schemas.microsoft.com/office/drawing/2017/decorative" val="1"/>
@@ -38110,7 +38116,7 @@
       </p:sp>
       <p:sp>
         <p:nvSpPr>
-          <p:cNvPr id="6" name="Decoration 1">
+          <p:cNvPr id="6" name="decoration#1">
             <a:extLst>
               <a:ext uri="{C183D7F6-B498-43B3-948B-1728B52AA6E4}">
                 <adec:decorative xmlns:adec="http://schemas.microsoft.com/office/drawing/2017/decorative" val="1"/>
@@ -39189,7 +39195,7 @@
       </p:sp>
       <p:sp>
         <p:nvSpPr>
-          <p:cNvPr id="3" name="Decoration 1">
+          <p:cNvPr id="3" name="decoration#1">
             <a:extLst>
               <a:ext uri="{C183D7F6-B498-43B3-948B-1728B52AA6E4}">
                 <adec:decorative xmlns:adec="http://schemas.microsoft.com/office/drawing/2017/decorative" val="1"/>
@@ -39392,7 +39398,7 @@
       </p:sp>
       <p:sp>
         <p:nvSpPr>
-          <p:cNvPr id="8" name="Decoration 2">
+          <p:cNvPr id="8" name="decoration#2">
             <a:extLst>
               <a:ext uri="{C183D7F6-B498-43B3-948B-1728B52AA6E4}">
                 <adec:decorative xmlns:adec="http://schemas.microsoft.com/office/drawing/2017/decorative" val="1"/>

</xml_diff>

<commit_message>
Logo slot on covers and the closing slide, filled from deck.json "logo"
An optional Logo field (role=logo) in a top corner of L-01 to L-05 and L-49,
drawn last so other shape ids do not change. build_deck.py fills every slot
from "logo" (PNG, JPG or SVG; next to deck.json, then cwd), scaled to fit
with its aspect ratio kept and aligned on the slot's side; "logo_alt" is the
alt text, else the logo is marked decorative. Without "logo" the slots are
removed and decks are byte-identical to before. A wrong file is a plain
error (exit 2). lint_deck.py warns when a logo overlaps text and accepts
decorative pictures without alt text.

Co-Authored-By: Claude Opus 5.5 <noreply@anthropic.com>
Claude-Session: https://claude.ai/code/session_01QPUPqERJ7izWceAQmUT86B
</commit_message>
<xml_diff>
--- a/skills/make-clean-pptx/assets/layouts.pptx
+++ b/skills/make-clean-pptx/assets/layouts.pptx
@@ -10442,6 +10442,26 @@
           </a:p>
         </p:txBody>
       </p:sp>
+      <p:sp>
+        <p:nvSpPr>
+          <p:cNvPr id="8" name="Logo"/>
+          <p:cNvSpPr/>
+          <p:nvPr/>
+        </p:nvSpPr>
+        <p:spPr>
+          <a:xfrm>
+            <a:off x="548640" y="457200"/>
+            <a:ext cx="1463040" cy="457200"/>
+          </a:xfrm>
+          <a:prstGeom prst="rect">
+            <a:avLst/>
+          </a:prstGeom>
+          <a:solidFill>
+            <a:schemeClr val="accent6"/>
+          </a:solidFill>
+          <a:ln/>
+        </p:spPr>
+      </p:sp>
     </p:spTree>
   </p:cSld>
   <p:clrMapOvr>
@@ -16020,6 +16040,26 @@
           </a:p>
         </p:txBody>
       </p:sp>
+      <p:sp>
+        <p:nvSpPr>
+          <p:cNvPr id="7" name="Logo"/>
+          <p:cNvSpPr/>
+          <p:nvPr/>
+        </p:nvSpPr>
+        <p:spPr>
+          <a:xfrm>
+            <a:off x="5364328" y="457200"/>
+            <a:ext cx="1463040" cy="457200"/>
+          </a:xfrm>
+          <a:prstGeom prst="rect">
+            <a:avLst/>
+          </a:prstGeom>
+          <a:solidFill>
+            <a:schemeClr val="accent6"/>
+          </a:solidFill>
+          <a:ln/>
+        </p:spPr>
+      </p:sp>
     </p:spTree>
   </p:cSld>
   <p:clrMapOvr>
@@ -22459,6 +22499,26 @@
             <a:endParaRPr lang="en-US" sz="1000" dirty="0"/>
           </a:p>
         </p:txBody>
+      </p:sp>
+      <p:sp>
+        <p:nvSpPr>
+          <p:cNvPr id="8" name="Logo"/>
+          <p:cNvSpPr/>
+          <p:nvPr/>
+        </p:nvSpPr>
+        <p:spPr>
+          <a:xfrm>
+            <a:off x="548640" y="457200"/>
+            <a:ext cx="1463040" cy="457200"/>
+          </a:xfrm>
+          <a:prstGeom prst="rect">
+            <a:avLst/>
+          </a:prstGeom>
+          <a:solidFill>
+            <a:schemeClr val="accent6"/>
+          </a:solidFill>
+          <a:ln/>
+        </p:spPr>
       </p:sp>
     </p:spTree>
   </p:cSld>
@@ -32750,6 +32810,26 @@
       </p:sp>
       <p:sp>
         <p:nvSpPr>
+          <p:cNvPr id="15" name="Logo"/>
+          <p:cNvSpPr/>
+          <p:nvPr/>
+        </p:nvSpPr>
+        <p:spPr>
+          <a:xfrm>
+            <a:off x="548640" y="457200"/>
+            <a:ext cx="1463040" cy="457200"/>
+          </a:xfrm>
+          <a:prstGeom prst="rect">
+            <a:avLst/>
+          </a:prstGeom>
+          <a:solidFill>
+            <a:schemeClr val="accent6"/>
+          </a:solidFill>
+          <a:ln/>
+        </p:spPr>
+      </p:sp>
+      <p:sp>
+        <p:nvSpPr>
           <p:cNvPr id="25" name="Slide Number Placeholder 0"/>
           <p:cNvSpPr>
             <a:spLocks noGrp="1"/>
@@ -33062,6 +33142,26 @@
             <a:endParaRPr lang="en-US" sz="1000" dirty="0"/>
           </a:p>
         </p:txBody>
+      </p:sp>
+      <p:sp>
+        <p:nvSpPr>
+          <p:cNvPr id="8" name="Logo"/>
+          <p:cNvSpPr/>
+          <p:nvPr/>
+        </p:nvSpPr>
+        <p:spPr>
+          <a:xfrm>
+            <a:off x="10180015" y="457200"/>
+            <a:ext cx="1463040" cy="457200"/>
+          </a:xfrm>
+          <a:prstGeom prst="rect">
+            <a:avLst/>
+          </a:prstGeom>
+          <a:solidFill>
+            <a:schemeClr val="accent6"/>
+          </a:solidFill>
+          <a:ln/>
+        </p:spPr>
       </p:sp>
     </p:spTree>
   </p:cSld>

</xml_diff>